<commit_message>
Use Practice consistently across site content and downloads
</commit_message>
<xml_diff>
--- a/dist/slides/u1-w15-l01.pptx
+++ b/dist/slides/u1-w15-l01.pptx
@@ -469,7 +469,7 @@
           </a:p>
           <a:p xmlns:a="http://schemas.openxmlformats.org/drawingml/2006/main">
             <a:r>
-              <a:t>Explain the goal and the expected independent outcome. Identify a specific skill to practise using evidence. This is ungraded textbook learning. Suggested times can be adjusted to the class. Teaching reference: https://edugenio.github.io/cs-atar-textbook/#consolidation. Use the current chapter and its linked resources.</a:t>
+              <a:t>Explain the goal and the expected independent outcome. Identify a specific skill to practice using evidence. This is ungraded textbook learning. Suggested times can be adjusted to the class. Teaching reference: https://edugenio.github.io/cs-atar-textbook/#consolidation. Use the current chapter and its linked resources.</a:t>
             </a:r>
           </a:p>
         </p:txBody>
@@ -3726,7 +3726,7 @@
                 <a:ea typeface="Arial"/>
                 <a:cs typeface="Arial"/>
               </a:rPr>
-              <a:t>Identify a specific skill to practise using evidence.</a:t>
+              <a:t>Identify a specific skill to practice using evidence.</a:t>
             </a:r>
           </a:p>
         </p:txBody>
@@ -5902,7 +5902,7 @@
                 <a:ea typeface="Arial"/>
                 <a:cs typeface="Arial"/>
               </a:rPr>
-              <a:t>A: Practise every topic for the same time.</a:t>
+              <a:t>A: Practice every topic for the same time.</a:t>
             </a:r>
           </a:p>
         </p:txBody>

</xml_diff>